<commit_message>
Implement reviewer-proposed FMCH fit improvements: primary care model, multi-way sensitivity, age scenarios, supplementary tables/figures
Co-Authored-By: Tatsuki Onishi <bougtoir@gmail.com>
</commit_message>
<xml_diff>
--- a/cancer_screening_burden/manuscript/manuscript_figures.pptx
+++ b/cancer_screening_burden/manuscript/manuscript_figures.pptx
@@ -9,6 +9,9 @@
     <p:sldId id="257" r:id="rId8"/>
     <p:sldId id="258" r:id="rId9"/>
     <p:sldId id="259" r:id="rId10"/>
+    <p:sldId id="260" r:id="rId11"/>
+    <p:sldId id="261" r:id="rId12"/>
+    <p:sldId id="262" r:id="rId13"/>
   </p:sldIdLst>
   <p:sldSz cx="12191695" cy="6858000" type="screen4x3"/>
   <p:notesSz cx="6858000" cy="9144000"/>
@@ -3359,6 +3362,225 @@
           <a:xfrm>
             <a:off x="914400" y="1188720"/>
             <a:ext cx="10058400" cy="6644115"/>
+          </a:xfrm>
+          <a:prstGeom prst="rect">
+            <a:avLst/>
+          </a:prstGeom>
+        </p:spPr>
+      </p:pic>
+    </p:spTree>
+  </p:cSld>
+  <p:clrMapOvr>
+    <a:masterClrMapping/>
+  </p:clrMapOvr>
+</p:sld>
+</file>
+
+<file path=ppt/slides/slide5.xml><?xml version="1.0" encoding="utf-8"?>
+<p:sld xmlns:a="http://schemas.openxmlformats.org/drawingml/2006/main" xmlns:p="http://schemas.openxmlformats.org/presentationml/2006/main" xmlns:r="http://schemas.openxmlformats.org/officeDocument/2006/relationships">
+  <p:cSld>
+    <p:spTree>
+      <p:nvGrpSpPr>
+        <p:cNvPr id="1" name=""/>
+        <p:cNvGrpSpPr/>
+        <p:nvPr/>
+      </p:nvGrpSpPr>
+      <p:grpSpPr/>
+      <p:sp>
+        <p:nvSpPr>
+          <p:cNvPr id="2" name="TextBox 1"/>
+          <p:cNvSpPr txBox="1"/>
+          <p:nvPr/>
+        </p:nvSpPr>
+        <p:spPr>
+          <a:xfrm>
+            <a:off x="457200" y="274320"/>
+            <a:ext cx="11247120" cy="731520"/>
+          </a:xfrm>
+          <a:prstGeom prst="rect">
+            <a:avLst/>
+          </a:prstGeom>
+          <a:noFill/>
+        </p:spPr>
+        <p:txBody>
+          <a:bodyPr wrap="none">
+            <a:spAutoFit/>
+          </a:bodyPr>
+          <a:lstStyle/>
+          <a:p>
+            <a:pPr>
+              <a:defRPr sz="2000" b="1"/>
+            </a:pPr>
+            <a:r>
+              <a:t>Supplementary Figure S1. One-way sensitivity of maximum capacity utilisation</a:t>
+            </a:r>
+          </a:p>
+        </p:txBody>
+      </p:sp>
+      <p:pic>
+        <p:nvPicPr>
+          <p:cNvPr id="3" name="Picture 2" descr="tornado_max_capacity.png"/>
+          <p:cNvPicPr>
+            <a:picLocks noChangeAspect="1"/>
+          </p:cNvPicPr>
+          <p:nvPr/>
+        </p:nvPicPr>
+        <p:blipFill>
+          <a:blip r:embed="rId2"/>
+          <a:stretch>
+            <a:fillRect/>
+          </a:stretch>
+        </p:blipFill>
+        <p:spPr>
+          <a:xfrm>
+            <a:off x="914400" y="1188720"/>
+            <a:ext cx="10058400" cy="5528914"/>
+          </a:xfrm>
+          <a:prstGeom prst="rect">
+            <a:avLst/>
+          </a:prstGeom>
+        </p:spPr>
+      </p:pic>
+    </p:spTree>
+  </p:cSld>
+  <p:clrMapOvr>
+    <a:masterClrMapping/>
+  </p:clrMapOvr>
+</p:sld>
+</file>
+
+<file path=ppt/slides/slide6.xml><?xml version="1.0" encoding="utf-8"?>
+<p:sld xmlns:a="http://schemas.openxmlformats.org/drawingml/2006/main" xmlns:p="http://schemas.openxmlformats.org/presentationml/2006/main" xmlns:r="http://schemas.openxmlformats.org/officeDocument/2006/relationships">
+  <p:cSld>
+    <p:spTree>
+      <p:nvGrpSpPr>
+        <p:cNvPr id="1" name=""/>
+        <p:cNvGrpSpPr/>
+        <p:nvPr/>
+      </p:nvGrpSpPr>
+      <p:grpSpPr/>
+      <p:sp>
+        <p:nvSpPr>
+          <p:cNvPr id="2" name="TextBox 1"/>
+          <p:cNvSpPr txBox="1"/>
+          <p:nvPr/>
+        </p:nvSpPr>
+        <p:spPr>
+          <a:xfrm>
+            <a:off x="457200" y="274320"/>
+            <a:ext cx="11247120" cy="731520"/>
+          </a:xfrm>
+          <a:prstGeom prst="rect">
+            <a:avLst/>
+          </a:prstGeom>
+          <a:noFill/>
+        </p:spPr>
+        <p:txBody>
+          <a:bodyPr wrap="none">
+            <a:spAutoFit/>
+          </a:bodyPr>
+          <a:lstStyle/>
+          <a:p>
+            <a:pPr>
+              <a:defRPr sz="2000" b="1"/>
+            </a:pPr>
+            <a:r>
+              <a:t>Supplementary Figure S2. One-way sensitivity of aggregate PPV</a:t>
+            </a:r>
+          </a:p>
+        </p:txBody>
+      </p:sp>
+      <p:pic>
+        <p:nvPicPr>
+          <p:cNvPr id="3" name="Picture 2" descr="tornado_ppv.png"/>
+          <p:cNvPicPr>
+            <a:picLocks noChangeAspect="1"/>
+          </p:cNvPicPr>
+          <p:nvPr/>
+        </p:nvPicPr>
+        <p:blipFill>
+          <a:blip r:embed="rId2"/>
+          <a:stretch>
+            <a:fillRect/>
+          </a:stretch>
+        </p:blipFill>
+        <p:spPr>
+          <a:xfrm>
+            <a:off x="914400" y="1188720"/>
+            <a:ext cx="10058400" cy="5528914"/>
+          </a:xfrm>
+          <a:prstGeom prst="rect">
+            <a:avLst/>
+          </a:prstGeom>
+        </p:spPr>
+      </p:pic>
+    </p:spTree>
+  </p:cSld>
+  <p:clrMapOvr>
+    <a:masterClrMapping/>
+  </p:clrMapOvr>
+</p:sld>
+</file>
+
+<file path=ppt/slides/slide7.xml><?xml version="1.0" encoding="utf-8"?>
+<p:sld xmlns:a="http://schemas.openxmlformats.org/drawingml/2006/main" xmlns:p="http://schemas.openxmlformats.org/presentationml/2006/main" xmlns:r="http://schemas.openxmlformats.org/officeDocument/2006/relationships">
+  <p:cSld>
+    <p:spTree>
+      <p:nvGrpSpPr>
+        <p:cNvPr id="1" name=""/>
+        <p:cNvGrpSpPr/>
+        <p:nvPr/>
+      </p:nvGrpSpPr>
+      <p:grpSpPr/>
+      <p:sp>
+        <p:nvSpPr>
+          <p:cNvPr id="2" name="TextBox 1"/>
+          <p:cNvSpPr txBox="1"/>
+          <p:nvPr/>
+        </p:nvSpPr>
+        <p:spPr>
+          <a:xfrm>
+            <a:off x="457200" y="274320"/>
+            <a:ext cx="11247120" cy="731520"/>
+          </a:xfrm>
+          <a:prstGeom prst="rect">
+            <a:avLst/>
+          </a:prstGeom>
+          <a:noFill/>
+        </p:spPr>
+        <p:txBody>
+          <a:bodyPr wrap="none">
+            <a:spAutoFit/>
+          </a:bodyPr>
+          <a:lstStyle/>
+          <a:p>
+            <a:pPr>
+              <a:defRPr sz="2000" b="1"/>
+            </a:pPr>
+            <a:r>
+              <a:t>Supplementary Figure S3. Aggregate PPV under alternative age-distribution scenarios</a:t>
+            </a:r>
+          </a:p>
+        </p:txBody>
+      </p:sp>
+      <p:pic>
+        <p:nvPicPr>
+          <p:cNvPr id="3" name="Picture 2" descr="age_scenario_ppv.png"/>
+          <p:cNvPicPr>
+            <a:picLocks noChangeAspect="1"/>
+          </p:cNvPicPr>
+          <p:nvPr/>
+        </p:nvPicPr>
+        <p:blipFill>
+          <a:blip r:embed="rId2"/>
+          <a:stretch>
+            <a:fillRect/>
+          </a:stretch>
+        </p:blipFill>
+        <p:spPr>
+          <a:xfrm>
+            <a:off x="914400" y="1188720"/>
+            <a:ext cx="10058400" cy="4972850"/>
           </a:xfrm>
           <a:prstGeom prst="rect">
             <a:avLst/>

</xml_diff>